<commit_message>
Fix arrows in diagrams for better visual clarity
</commit_message>
<xml_diff>
--- a/docs/BOB_Presentation.pptx
+++ b/docs/BOB_Presentation.pptx
@@ -6587,7 +6587,7 @@
         <p:spPr>
           <a:xfrm>
             <a:off x="6400800" y="1371600"/>
-            <a:ext cx="5486400" cy="3269673"/>
+            <a:ext cx="5486400" cy="2720148"/>
           </a:xfrm>
           <a:prstGeom prst="rect">
             <a:avLst/>
@@ -7769,7 +7769,7 @@
         <p:spPr>
           <a:xfrm>
             <a:off x="457200" y="1188720"/>
-            <a:ext cx="11277295" cy="7486608"/>
+            <a:ext cx="11277295" cy="7220714"/>
           </a:xfrm>
           <a:prstGeom prst="rect">
             <a:avLst/>
@@ -7924,7 +7924,7 @@
         <p:spPr>
           <a:xfrm>
             <a:off x="274320" y="1097280"/>
-            <a:ext cx="7315200" cy="5837382"/>
+            <a:ext cx="7315200" cy="5489484"/>
           </a:xfrm>
           <a:prstGeom prst="rect">
             <a:avLst/>
@@ -8269,7 +8269,7 @@
         <p:spPr>
           <a:xfrm>
             <a:off x="274320" y="1188720"/>
-            <a:ext cx="11430000" cy="5666975"/>
+            <a:ext cx="11430000" cy="4851583"/>
           </a:xfrm>
           <a:prstGeom prst="rect">
             <a:avLst/>
@@ -8494,7 +8494,7 @@
         <p:spPr>
           <a:xfrm>
             <a:off x="274320" y="1188720"/>
-            <a:ext cx="11430000" cy="5666975"/>
+            <a:ext cx="11430000" cy="5673885"/>
           </a:xfrm>
           <a:prstGeom prst="rect">
             <a:avLst/>
@@ -8732,7 +8732,7 @@
         <p:spPr>
           <a:xfrm>
             <a:off x="457200" y="1188720"/>
-            <a:ext cx="11277295" cy="7486608"/>
+            <a:ext cx="11277295" cy="6409398"/>
           </a:xfrm>
           <a:prstGeom prst="rect">
             <a:avLst/>
@@ -8887,7 +8887,7 @@
         <p:spPr>
           <a:xfrm>
             <a:off x="457200" y="1371600"/>
-            <a:ext cx="5486400" cy="3262284"/>
+            <a:ext cx="5486400" cy="3251200"/>
           </a:xfrm>
           <a:prstGeom prst="rect">
             <a:avLst/>

</xml_diff>

<commit_message>
Fix slides 4, 5, 11: better layout, larger text, more content in spec examples
</commit_message>
<xml_diff>
--- a/docs/BOB_Presentation.pptx
+++ b/docs/BOB_Presentation.pptx
@@ -4433,19 +4433,17 @@
         </p:nvSpPr>
         <p:spPr>
           <a:xfrm>
-            <a:off x="457200" y="1371600"/>
-            <a:ext cx="2743200" cy="3200400"/>
+            <a:off x="457200" y="1280160"/>
+            <a:ext cx="2651760" cy="411480"/>
           </a:xfrm>
           <a:prstGeom prst="roundRect">
             <a:avLst/>
           </a:prstGeom>
           <a:solidFill>
-            <a:srgbClr val="F5F5F5"/>
+            <a:srgbClr val="2196F3"/>
           </a:solidFill>
           <a:ln>
-            <a:solidFill>
-              <a:srgbClr val="2196F3"/>
-            </a:solidFill>
+            <a:noFill/>
           </a:ln>
         </p:spPr>
         <p:style>
@@ -4478,8 +4476,8 @@
         </p:nvSpPr>
         <p:spPr>
           <a:xfrm>
-            <a:off x="548640" y="1463040"/>
-            <a:ext cx="2560320" cy="365760"/>
+            <a:off x="548640" y="1325880"/>
+            <a:ext cx="2468879" cy="365760"/>
           </a:xfrm>
           <a:prstGeom prst="rect">
             <a:avLst/>
@@ -4493,9 +4491,9 @@
           <a:lstStyle/>
           <a:p>
             <a:pPr algn="l">
-              <a:defRPr sz="1400" b="1">
-                <a:solidFill>
-                  <a:srgbClr val="2196F3"/>
+              <a:defRPr sz="1300" b="1">
+                <a:solidFill>
+                  <a:srgbClr val="FFFFFF"/>
                 </a:solidFill>
               </a:defRPr>
             </a:pPr>
@@ -4507,63 +4505,16 @@
       </p:sp>
       <p:sp>
         <p:nvSpPr>
-          <p:cNvPr id="7" name="TextBox 6"/>
-          <p:cNvSpPr txBox="1"/>
-          <p:nvPr/>
-        </p:nvSpPr>
-        <p:spPr>
-          <a:xfrm>
-            <a:off x="548640" y="1920240"/>
-            <a:ext cx="2560320" cy="2560320"/>
-          </a:xfrm>
-          <a:prstGeom prst="rect">
-            <a:avLst/>
-          </a:prstGeom>
-          <a:noFill/>
-        </p:spPr>
-        <p:txBody>
-          <a:bodyPr wrap="square">
-            <a:spAutoFit/>
-          </a:bodyPr>
-          <a:lstStyle/>
-          <a:p>
-            <a:pPr algn="l">
-              <a:defRPr sz="1000" b="0">
-                <a:solidFill>
-                  <a:srgbClr val="212121"/>
-                </a:solidFill>
-              </a:defRPr>
-            </a:pPr>
-            <a:r>
-              <a:t>tasks:</a:t>
-            </a:r>
-            <a:br/>
-            <a:r>
-              <a:t>  - id: auth</a:t>
-            </a:r>
-            <a:br/>
-            <a:r>
-              <a:t>    title: User Auth</a:t>
-            </a:r>
-            <a:br/>
-            <a:r>
-              <a:t>    priority: critical</a:t>
-            </a:r>
-          </a:p>
-        </p:txBody>
-      </p:sp>
-      <p:sp>
-        <p:nvSpPr>
-          <p:cNvPr id="8" name="Rounded Rectangle 7"/>
+          <p:cNvPr id="7" name="Rectangle 6"/>
           <p:cNvSpPr/>
           <p:nvPr/>
         </p:nvSpPr>
         <p:spPr>
           <a:xfrm>
-            <a:off x="3383280" y="1371600"/>
-            <a:ext cx="2743200" cy="3200400"/>
-          </a:xfrm>
-          <a:prstGeom prst="roundRect">
+            <a:off x="457200" y="1691640"/>
+            <a:ext cx="2651760" cy="3200400"/>
+          </a:xfrm>
+          <a:prstGeom prst="rect">
             <a:avLst/>
           </a:prstGeom>
           <a:solidFill>
@@ -4571,7 +4522,7 @@
           </a:solidFill>
           <a:ln>
             <a:solidFill>
-              <a:srgbClr val="FF9800"/>
+              <a:srgbClr val="2196F3"/>
             </a:solidFill>
           </a:ln>
         </p:spPr>
@@ -4599,14 +4550,14 @@
       </p:sp>
       <p:sp>
         <p:nvSpPr>
-          <p:cNvPr id="9" name="TextBox 8"/>
-          <p:cNvSpPr txBox="1"/>
-          <p:nvPr/>
-        </p:nvSpPr>
-        <p:spPr>
-          <a:xfrm>
-            <a:off x="3474720" y="1463040"/>
-            <a:ext cx="2560320" cy="365760"/>
+          <p:cNvPr id="8" name="TextBox 7"/>
+          <p:cNvSpPr txBox="1"/>
+          <p:nvPr/>
+        </p:nvSpPr>
+        <p:spPr>
+          <a:xfrm>
+            <a:off x="548640" y="1783080"/>
+            <a:ext cx="2468879" cy="3017520"/>
           </a:xfrm>
           <a:prstGeom prst="rect">
             <a:avLst/>
@@ -4619,87 +4570,75 @@
           </a:bodyPr>
           <a:lstStyle/>
           <a:p>
-            <a:pPr algn="l">
-              <a:defRPr sz="1400" b="1">
-                <a:solidFill>
-                  <a:srgbClr val="FF9800"/>
-                </a:solidFill>
-              </a:defRPr>
-            </a:pPr>
-            <a:r>
-              <a:t>JSON</a:t>
-            </a:r>
-          </a:p>
-        </p:txBody>
-      </p:sp>
-      <p:sp>
-        <p:nvSpPr>
-          <p:cNvPr id="10" name="TextBox 9"/>
-          <p:cNvSpPr txBox="1"/>
-          <p:nvPr/>
-        </p:nvSpPr>
-        <p:spPr>
-          <a:xfrm>
-            <a:off x="3474720" y="1920240"/>
-            <a:ext cx="2560320" cy="2560320"/>
-          </a:xfrm>
-          <a:prstGeom prst="rect">
-            <a:avLst/>
-          </a:prstGeom>
-          <a:noFill/>
-        </p:spPr>
-        <p:txBody>
-          <a:bodyPr wrap="square">
-            <a:spAutoFit/>
-          </a:bodyPr>
-          <a:lstStyle/>
-          <a:p>
-            <a:pPr algn="l">
-              <a:defRPr sz="1000" b="0">
+            <a:pPr>
+              <a:defRPr sz="900">
                 <a:solidFill>
                   <a:srgbClr val="212121"/>
                 </a:solidFill>
               </a:defRPr>
             </a:pPr>
             <a:r>
-              <a:t>{"tasks": [</a:t>
+              <a:t>name: My App</a:t>
             </a:r>
             <a:br/>
-            <a:r>
-              <a:t>  {"id": "auth",</a:t>
-            </a:r>
             <a:br/>
             <a:r>
-              <a:t>   "title": "User Auth"}</a:t>
+              <a:t>tasks:</a:t>
             </a:r>
             <a:br/>
             <a:r>
-              <a:t>]}</a:t>
-            </a:r>
-          </a:p>
-        </p:txBody>
-      </p:sp>
-      <p:sp>
-        <p:nvSpPr>
-          <p:cNvPr id="11" name="Rounded Rectangle 10"/>
+              <a:t>  - id: auth</a:t>
+            </a:r>
+            <a:br/>
+            <a:r>
+              <a:t>    title: User Auth</a:t>
+            </a:r>
+            <a:br/>
+            <a:r>
+              <a:t>    priority: critical</a:t>
+            </a:r>
+            <a:br/>
+            <a:r>
+              <a:t>    depends_on:</a:t>
+            </a:r>
+            <a:br/>
+            <a:r>
+              <a:t>      - database</a:t>
+            </a:r>
+            <a:br/>
+            <a:r>
+              <a:t>    acceptance_criteria:</a:t>
+            </a:r>
+            <a:br/>
+            <a:r>
+              <a:t>      - Login works</a:t>
+            </a:r>
+            <a:br/>
+            <a:r>
+              <a:t>      - Logout works</a:t>
+            </a:r>
+          </a:p>
+        </p:txBody>
+      </p:sp>
+      <p:sp>
+        <p:nvSpPr>
+          <p:cNvPr id="9" name="Rounded Rectangle 8"/>
           <p:cNvSpPr/>
           <p:nvPr/>
         </p:nvSpPr>
         <p:spPr>
           <a:xfrm>
-            <a:off x="6309360" y="1371600"/>
-            <a:ext cx="2743200" cy="3200400"/>
+            <a:off x="3383280" y="1280160"/>
+            <a:ext cx="2651760" cy="411480"/>
           </a:xfrm>
           <a:prstGeom prst="roundRect">
             <a:avLst/>
           </a:prstGeom>
           <a:solidFill>
-            <a:srgbClr val="F5F5F5"/>
+            <a:srgbClr val="FF9800"/>
           </a:solidFill>
           <a:ln>
-            <a:solidFill>
-              <a:srgbClr val="4CAF50"/>
-            </a:solidFill>
+            <a:noFill/>
           </a:ln>
         </p:spPr>
         <p:style>
@@ -4726,14 +4665,14 @@
       </p:sp>
       <p:sp>
         <p:nvSpPr>
-          <p:cNvPr id="12" name="TextBox 11"/>
-          <p:cNvSpPr txBox="1"/>
-          <p:nvPr/>
-        </p:nvSpPr>
-        <p:spPr>
-          <a:xfrm>
-            <a:off x="6400800" y="1463040"/>
-            <a:ext cx="2560320" cy="365760"/>
+          <p:cNvPr id="10" name="TextBox 9"/>
+          <p:cNvSpPr txBox="1"/>
+          <p:nvPr/>
+        </p:nvSpPr>
+        <p:spPr>
+          <a:xfrm>
+            <a:off x="3474720" y="1325880"/>
+            <a:ext cx="2468879" cy="365760"/>
           </a:xfrm>
           <a:prstGeom prst="rect">
             <a:avLst/>
@@ -4747,78 +4686,30 @@
           <a:lstStyle/>
           <a:p>
             <a:pPr algn="l">
-              <a:defRPr sz="1400" b="1">
-                <a:solidFill>
-                  <a:srgbClr val="4CAF50"/>
-                </a:solidFill>
-              </a:defRPr>
-            </a:pPr>
-            <a:r>
-              <a:t>Markdown</a:t>
-            </a:r>
-          </a:p>
-        </p:txBody>
-      </p:sp>
-      <p:sp>
-        <p:nvSpPr>
-          <p:cNvPr id="13" name="TextBox 12"/>
-          <p:cNvSpPr txBox="1"/>
-          <p:nvPr/>
-        </p:nvSpPr>
-        <p:spPr>
-          <a:xfrm>
-            <a:off x="6400800" y="1920240"/>
-            <a:ext cx="2560320" cy="2560320"/>
-          </a:xfrm>
-          <a:prstGeom prst="rect">
-            <a:avLst/>
-          </a:prstGeom>
-          <a:noFill/>
-        </p:spPr>
-        <p:txBody>
-          <a:bodyPr wrap="square">
-            <a:spAutoFit/>
-          </a:bodyPr>
-          <a:lstStyle/>
-          <a:p>
-            <a:pPr algn="l">
-              <a:defRPr sz="1000" b="0">
-                <a:solidFill>
-                  <a:srgbClr val="212121"/>
-                </a:solidFill>
-              </a:defRPr>
-            </a:pPr>
-            <a:r>
-              <a:t>## auth: User Auth</a:t>
-            </a:r>
-            <a:br/>
-            <a:r>
-              <a:t>[priority:critical]</a:t>
-            </a:r>
-            <a:br/>
-            <a:br/>
-            <a:r>
-              <a:t>### Criteria</a:t>
-            </a:r>
-            <a:br/>
-            <a:r>
-              <a:t>- Login works</a:t>
-            </a:r>
-          </a:p>
-        </p:txBody>
-      </p:sp>
-      <p:sp>
-        <p:nvSpPr>
-          <p:cNvPr id="14" name="Rounded Rectangle 13"/>
+              <a:defRPr sz="1300" b="1">
+                <a:solidFill>
+                  <a:srgbClr val="FFFFFF"/>
+                </a:solidFill>
+              </a:defRPr>
+            </a:pPr>
+            <a:r>
+              <a:t>JSON</a:t>
+            </a:r>
+          </a:p>
+        </p:txBody>
+      </p:sp>
+      <p:sp>
+        <p:nvSpPr>
+          <p:cNvPr id="11" name="Rectangle 10"/>
           <p:cNvSpPr/>
           <p:nvPr/>
         </p:nvSpPr>
         <p:spPr>
           <a:xfrm>
-            <a:off x="9235440" y="1371600"/>
-            <a:ext cx="2743200" cy="3200400"/>
-          </a:xfrm>
-          <a:prstGeom prst="roundRect">
+            <a:off x="3383280" y="1691640"/>
+            <a:ext cx="2651760" cy="3200400"/>
+          </a:xfrm>
+          <a:prstGeom prst="rect">
             <a:avLst/>
           </a:prstGeom>
           <a:solidFill>
@@ -4826,7 +4717,7 @@
           </a:solidFill>
           <a:ln>
             <a:solidFill>
-              <a:srgbClr val="0D47A1"/>
+              <a:srgbClr val="FF9800"/>
             </a:solidFill>
           </a:ln>
         </p:spPr>
@@ -4854,14 +4745,14 @@
       </p:sp>
       <p:sp>
         <p:nvSpPr>
-          <p:cNvPr id="15" name="TextBox 14"/>
-          <p:cNvSpPr txBox="1"/>
-          <p:nvPr/>
-        </p:nvSpPr>
-        <p:spPr>
-          <a:xfrm>
-            <a:off x="9326880" y="1463040"/>
-            <a:ext cx="2560320" cy="365760"/>
+          <p:cNvPr id="12" name="TextBox 11"/>
+          <p:cNvSpPr txBox="1"/>
+          <p:nvPr/>
+        </p:nvSpPr>
+        <p:spPr>
+          <a:xfrm>
+            <a:off x="3474720" y="1783080"/>
+            <a:ext cx="2468879" cy="3017520"/>
           </a:xfrm>
           <a:prstGeom prst="rect">
             <a:avLst/>
@@ -4874,16 +4765,179 @@
           </a:bodyPr>
           <a:lstStyle/>
           <a:p>
+            <a:pPr>
+              <a:defRPr sz="900">
+                <a:solidFill>
+                  <a:srgbClr val="212121"/>
+                </a:solidFill>
+              </a:defRPr>
+            </a:pPr>
+            <a:r>
+              <a:t>{</a:t>
+            </a:r>
+            <a:br/>
+            <a:r>
+              <a:t>  "name": "My App",</a:t>
+            </a:r>
+            <a:br/>
+            <a:r>
+              <a:t>  "tasks": [{</a:t>
+            </a:r>
+            <a:br/>
+            <a:r>
+              <a:t>    "id": "auth",</a:t>
+            </a:r>
+            <a:br/>
+            <a:r>
+              <a:t>    "title": "User Auth",</a:t>
+            </a:r>
+            <a:br/>
+            <a:r>
+              <a:t>    "priority": "critical",</a:t>
+            </a:r>
+            <a:br/>
+            <a:r>
+              <a:t>    "depends_on": [</a:t>
+            </a:r>
+            <a:br/>
+            <a:r>
+              <a:t>      "database"</a:t>
+            </a:r>
+            <a:br/>
+            <a:r>
+              <a:t>    ]</a:t>
+            </a:r>
+            <a:br/>
+            <a:r>
+              <a:t>  }]</a:t>
+            </a:r>
+            <a:br/>
+            <a:r>
+              <a:t>}</a:t>
+            </a:r>
+          </a:p>
+        </p:txBody>
+      </p:sp>
+      <p:sp>
+        <p:nvSpPr>
+          <p:cNvPr id="13" name="Rounded Rectangle 12"/>
+          <p:cNvSpPr/>
+          <p:nvPr/>
+        </p:nvSpPr>
+        <p:spPr>
+          <a:xfrm>
+            <a:off x="6309360" y="1280160"/>
+            <a:ext cx="2651760" cy="411480"/>
+          </a:xfrm>
+          <a:prstGeom prst="roundRect">
+            <a:avLst/>
+          </a:prstGeom>
+          <a:solidFill>
+            <a:srgbClr val="4CAF50"/>
+          </a:solidFill>
+          <a:ln>
+            <a:noFill/>
+          </a:ln>
+        </p:spPr>
+        <p:style>
+          <a:lnRef idx="1">
+            <a:schemeClr val="accent1"/>
+          </a:lnRef>
+          <a:fillRef idx="3">
+            <a:schemeClr val="accent1"/>
+          </a:fillRef>
+          <a:effectRef idx="2">
+            <a:schemeClr val="accent1"/>
+          </a:effectRef>
+          <a:fontRef idx="minor">
+            <a:schemeClr val="lt1"/>
+          </a:fontRef>
+        </p:style>
+        <p:txBody>
+          <a:bodyPr rtlCol="0" anchor="ctr"/>
+          <a:lstStyle/>
+          <a:p>
+            <a:pPr algn="ctr"/>
+          </a:p>
+        </p:txBody>
+      </p:sp>
+      <p:sp>
+        <p:nvSpPr>
+          <p:cNvPr id="14" name="TextBox 13"/>
+          <p:cNvSpPr txBox="1"/>
+          <p:nvPr/>
+        </p:nvSpPr>
+        <p:spPr>
+          <a:xfrm>
+            <a:off x="6400800" y="1325880"/>
+            <a:ext cx="2468879" cy="365760"/>
+          </a:xfrm>
+          <a:prstGeom prst="rect">
+            <a:avLst/>
+          </a:prstGeom>
+          <a:noFill/>
+        </p:spPr>
+        <p:txBody>
+          <a:bodyPr wrap="square">
+            <a:spAutoFit/>
+          </a:bodyPr>
+          <a:lstStyle/>
+          <a:p>
             <a:pPr algn="l">
-              <a:defRPr sz="1400" b="1">
-                <a:solidFill>
-                  <a:srgbClr val="0D47A1"/>
-                </a:solidFill>
-              </a:defRPr>
-            </a:pPr>
-            <a:r>
-              <a:t>GitHub Issues</a:t>
-            </a:r>
+              <a:defRPr sz="1300" b="1">
+                <a:solidFill>
+                  <a:srgbClr val="FFFFFF"/>
+                </a:solidFill>
+              </a:defRPr>
+            </a:pPr>
+            <a:r>
+              <a:t>Markdown</a:t>
+            </a:r>
+          </a:p>
+        </p:txBody>
+      </p:sp>
+      <p:sp>
+        <p:nvSpPr>
+          <p:cNvPr id="15" name="Rectangle 14"/>
+          <p:cNvSpPr/>
+          <p:nvPr/>
+        </p:nvSpPr>
+        <p:spPr>
+          <a:xfrm>
+            <a:off x="6309360" y="1691640"/>
+            <a:ext cx="2651760" cy="3200400"/>
+          </a:xfrm>
+          <a:prstGeom prst="rect">
+            <a:avLst/>
+          </a:prstGeom>
+          <a:solidFill>
+            <a:srgbClr val="F5F5F5"/>
+          </a:solidFill>
+          <a:ln>
+            <a:solidFill>
+              <a:srgbClr val="4CAF50"/>
+            </a:solidFill>
+          </a:ln>
+        </p:spPr>
+        <p:style>
+          <a:lnRef idx="1">
+            <a:schemeClr val="accent1"/>
+          </a:lnRef>
+          <a:fillRef idx="3">
+            <a:schemeClr val="accent1"/>
+          </a:fillRef>
+          <a:effectRef idx="2">
+            <a:schemeClr val="accent1"/>
+          </a:effectRef>
+          <a:fontRef idx="minor">
+            <a:schemeClr val="lt1"/>
+          </a:fontRef>
+        </p:style>
+        <p:txBody>
+          <a:bodyPr rtlCol="0" anchor="ctr"/>
+          <a:lstStyle/>
+          <a:p>
+            <a:pPr algn="ctr"/>
           </a:p>
         </p:txBody>
       </p:sp>
@@ -4895,8 +4949,8 @@
         </p:nvSpPr>
         <p:spPr>
           <a:xfrm>
-            <a:off x="9326880" y="1920240"/>
-            <a:ext cx="2560320" cy="2560320"/>
+            <a:off x="6400800" y="1783080"/>
+            <a:ext cx="2468879" cy="3017520"/>
           </a:xfrm>
           <a:prstGeom prst="rect">
             <a:avLst/>
@@ -4909,38 +4963,252 @@
           </a:bodyPr>
           <a:lstStyle/>
           <a:p>
-            <a:pPr algn="l">
-              <a:defRPr sz="1000" b="0">
+            <a:pPr>
+              <a:defRPr sz="900">
                 <a:solidFill>
                   <a:srgbClr val="212121"/>
                 </a:solidFill>
               </a:defRPr>
             </a:pPr>
             <a:r>
-              <a:t>Issue #42: User Auth</a:t>
-            </a:r>
-            <a:br/>
-            <a:r>
-              <a:t>Labels: ai-implement</a:t>
+              <a:t># My App Spec</a:t>
             </a:r>
             <a:br/>
             <a:br/>
             <a:r>
-              <a:t>Checkboxes as criteria</a:t>
-            </a:r>
-          </a:p>
-        </p:txBody>
-      </p:sp>
-      <p:sp>
-        <p:nvSpPr>
-          <p:cNvPr id="17" name="TextBox 16"/>
-          <p:cNvSpPr txBox="1"/>
-          <p:nvPr/>
-        </p:nvSpPr>
-        <p:spPr>
-          <a:xfrm>
-            <a:off x="457200" y="5029200"/>
-            <a:ext cx="10972800" cy="365760"/>
+              <a:t>## auth: User Auth</a:t>
+            </a:r>
+            <a:br/>
+            <a:r>
+              <a:t>[priority:critical]</a:t>
+            </a:r>
+            <a:br/>
+            <a:r>
+              <a:t>[depends:database]</a:t>
+            </a:r>
+            <a:br/>
+            <a:br/>
+            <a:r>
+              <a:t>Implement user</a:t>
+            </a:r>
+            <a:br/>
+            <a:r>
+              <a:t>authentication.</a:t>
+            </a:r>
+            <a:br/>
+            <a:br/>
+            <a:r>
+              <a:t>### Criteria</a:t>
+            </a:r>
+            <a:br/>
+            <a:r>
+              <a:t>- Login works</a:t>
+            </a:r>
+            <a:br/>
+            <a:r>
+              <a:t>- Logout works</a:t>
+            </a:r>
+          </a:p>
+        </p:txBody>
+      </p:sp>
+      <p:sp>
+        <p:nvSpPr>
+          <p:cNvPr id="17" name="Rounded Rectangle 16"/>
+          <p:cNvSpPr/>
+          <p:nvPr/>
+        </p:nvSpPr>
+        <p:spPr>
+          <a:xfrm>
+            <a:off x="9235440" y="1280160"/>
+            <a:ext cx="2651760" cy="411480"/>
+          </a:xfrm>
+          <a:prstGeom prst="roundRect">
+            <a:avLst/>
+          </a:prstGeom>
+          <a:solidFill>
+            <a:srgbClr val="0D47A1"/>
+          </a:solidFill>
+          <a:ln>
+            <a:noFill/>
+          </a:ln>
+        </p:spPr>
+        <p:style>
+          <a:lnRef idx="1">
+            <a:schemeClr val="accent1"/>
+          </a:lnRef>
+          <a:fillRef idx="3">
+            <a:schemeClr val="accent1"/>
+          </a:fillRef>
+          <a:effectRef idx="2">
+            <a:schemeClr val="accent1"/>
+          </a:effectRef>
+          <a:fontRef idx="minor">
+            <a:schemeClr val="lt1"/>
+          </a:fontRef>
+        </p:style>
+        <p:txBody>
+          <a:bodyPr rtlCol="0" anchor="ctr"/>
+          <a:lstStyle/>
+          <a:p>
+            <a:pPr algn="ctr"/>
+          </a:p>
+        </p:txBody>
+      </p:sp>
+      <p:sp>
+        <p:nvSpPr>
+          <p:cNvPr id="18" name="TextBox 17"/>
+          <p:cNvSpPr txBox="1"/>
+          <p:nvPr/>
+        </p:nvSpPr>
+        <p:spPr>
+          <a:xfrm>
+            <a:off x="9326880" y="1325880"/>
+            <a:ext cx="2468879" cy="365760"/>
+          </a:xfrm>
+          <a:prstGeom prst="rect">
+            <a:avLst/>
+          </a:prstGeom>
+          <a:noFill/>
+        </p:spPr>
+        <p:txBody>
+          <a:bodyPr wrap="square">
+            <a:spAutoFit/>
+          </a:bodyPr>
+          <a:lstStyle/>
+          <a:p>
+            <a:pPr algn="l">
+              <a:defRPr sz="1300" b="1">
+                <a:solidFill>
+                  <a:srgbClr val="FFFFFF"/>
+                </a:solidFill>
+              </a:defRPr>
+            </a:pPr>
+            <a:r>
+              <a:t>GitHub Issues</a:t>
+            </a:r>
+          </a:p>
+        </p:txBody>
+      </p:sp>
+      <p:sp>
+        <p:nvSpPr>
+          <p:cNvPr id="19" name="Rectangle 18"/>
+          <p:cNvSpPr/>
+          <p:nvPr/>
+        </p:nvSpPr>
+        <p:spPr>
+          <a:xfrm>
+            <a:off x="9235440" y="1691640"/>
+            <a:ext cx="2651760" cy="3200400"/>
+          </a:xfrm>
+          <a:prstGeom prst="rect">
+            <a:avLst/>
+          </a:prstGeom>
+          <a:solidFill>
+            <a:srgbClr val="F5F5F5"/>
+          </a:solidFill>
+          <a:ln>
+            <a:solidFill>
+              <a:srgbClr val="0D47A1"/>
+            </a:solidFill>
+          </a:ln>
+        </p:spPr>
+        <p:style>
+          <a:lnRef idx="1">
+            <a:schemeClr val="accent1"/>
+          </a:lnRef>
+          <a:fillRef idx="3">
+            <a:schemeClr val="accent1"/>
+          </a:fillRef>
+          <a:effectRef idx="2">
+            <a:schemeClr val="accent1"/>
+          </a:effectRef>
+          <a:fontRef idx="minor">
+            <a:schemeClr val="lt1"/>
+          </a:fontRef>
+        </p:style>
+        <p:txBody>
+          <a:bodyPr rtlCol="0" anchor="ctr"/>
+          <a:lstStyle/>
+          <a:p>
+            <a:pPr algn="ctr"/>
+          </a:p>
+        </p:txBody>
+      </p:sp>
+      <p:sp>
+        <p:nvSpPr>
+          <p:cNvPr id="20" name="TextBox 19"/>
+          <p:cNvSpPr txBox="1"/>
+          <p:nvPr/>
+        </p:nvSpPr>
+        <p:spPr>
+          <a:xfrm>
+            <a:off x="9326880" y="1783080"/>
+            <a:ext cx="2468879" cy="3017520"/>
+          </a:xfrm>
+          <a:prstGeom prst="rect">
+            <a:avLst/>
+          </a:prstGeom>
+          <a:noFill/>
+        </p:spPr>
+        <p:txBody>
+          <a:bodyPr wrap="square">
+            <a:spAutoFit/>
+          </a:bodyPr>
+          <a:lstStyle/>
+          <a:p>
+            <a:pPr>
+              <a:defRPr sz="900">
+                <a:solidFill>
+                  <a:srgbClr val="212121"/>
+                </a:solidFill>
+              </a:defRPr>
+            </a:pPr>
+            <a:r>
+              <a:t>Issue #42</a:t>
+            </a:r>
+            <a:br/>
+            <a:r>
+              <a:t>Title: User Auth</a:t>
+            </a:r>
+            <a:br/>
+            <a:br/>
+            <a:r>
+              <a:t>Labels:</a:t>
+            </a:r>
+            <a:br/>
+            <a:r>
+              <a:t>  - ai-implement</a:t>
+            </a:r>
+            <a:br/>
+            <a:r>
+              <a:t>  - priority-critical</a:t>
+            </a:r>
+            <a:br/>
+            <a:br/>
+            <a:r>
+              <a:t>Acceptance:</a:t>
+            </a:r>
+            <a:br/>
+            <a:r>
+              <a:t>- [ ] Login works</a:t>
+            </a:r>
+            <a:br/>
+            <a:r>
+              <a:t>- [ ] Logout works</a:t>
+            </a:r>
+          </a:p>
+        </p:txBody>
+      </p:sp>
+      <p:sp>
+        <p:nvSpPr>
+          <p:cNvPr id="21" name="TextBox 20"/>
+          <p:cNvSpPr txBox="1"/>
+          <p:nvPr/>
+        </p:nvSpPr>
+        <p:spPr>
+          <a:xfrm>
+            <a:off x="457200" y="5120640"/>
+            <a:ext cx="11277295" cy="365760"/>
           </a:xfrm>
           <a:prstGeom prst="rect">
             <a:avLst/>
@@ -4961,21 +5229,21 @@
               </a:defRPr>
             </a:pPr>
             <a:r>
-              <a:t>$ bob project create app ./work github://org/repo?label=ai-implement</a:t>
-            </a:r>
-          </a:p>
-        </p:txBody>
-      </p:sp>
-      <p:sp>
-        <p:nvSpPr>
-          <p:cNvPr id="18" name="TextBox 17"/>
-          <p:cNvSpPr txBox="1"/>
-          <p:nvPr/>
-        </p:nvSpPr>
-        <p:spPr>
-          <a:xfrm>
-            <a:off x="457200" y="5486400"/>
-            <a:ext cx="10972800" cy="365760"/>
+              <a:t>$ bob project create app ./workspace github://org/repo?label=ai-implement</a:t>
+            </a:r>
+          </a:p>
+        </p:txBody>
+      </p:sp>
+      <p:sp>
+        <p:nvSpPr>
+          <p:cNvPr id="22" name="TextBox 21"/>
+          <p:cNvSpPr txBox="1"/>
+          <p:nvPr/>
+        </p:nvSpPr>
+        <p:spPr>
+          <a:xfrm>
+            <a:off x="457200" y="5577840"/>
+            <a:ext cx="11277295" cy="365760"/>
           </a:xfrm>
           <a:prstGeom prst="rect">
             <a:avLst/>
@@ -4989,14 +5257,14 @@
           <a:lstStyle/>
           <a:p>
             <a:pPr algn="ctr">
-              <a:defRPr sz="1300" b="0">
+              <a:defRPr sz="1200" b="0">
                 <a:solidFill>
                   <a:srgbClr val="616161"/>
                 </a:solidFill>
               </a:defRPr>
             </a:pPr>
             <a:r>
-              <a:t>Sync GitHub issues directly as tasks!</a:t>
+              <a:t>Sync GitHub issues directly as tasks - labels become priorities and metadata!</a:t>
             </a:r>
           </a:p>
         </p:txBody>
@@ -5873,7 +6141,7 @@
         <p:spPr>
           <a:xfrm>
             <a:off x="457200" y="5669280"/>
-            <a:ext cx="10972800" cy="365760"/>
+            <a:ext cx="11277295" cy="365760"/>
           </a:xfrm>
           <a:prstGeom prst="rect">
             <a:avLst/>
@@ -7768,14 +8036,273 @@
         </p:blipFill>
         <p:spPr>
           <a:xfrm>
-            <a:off x="457200" y="1188720"/>
-            <a:ext cx="11277295" cy="7220714"/>
+            <a:off x="274320" y="1097280"/>
+            <a:ext cx="7772400" cy="4976573"/>
           </a:xfrm>
           <a:prstGeom prst="rect">
             <a:avLst/>
           </a:prstGeom>
         </p:spPr>
       </p:pic>
+      <p:sp>
+        <p:nvSpPr>
+          <p:cNvPr id="6" name="TextBox 5"/>
+          <p:cNvSpPr txBox="1"/>
+          <p:nvPr/>
+        </p:nvSpPr>
+        <p:spPr>
+          <a:xfrm>
+            <a:off x="8229600" y="1371600"/>
+            <a:ext cx="3657600" cy="365760"/>
+          </a:xfrm>
+          <a:prstGeom prst="rect">
+            <a:avLst/>
+          </a:prstGeom>
+          <a:noFill/>
+        </p:spPr>
+        <p:txBody>
+          <a:bodyPr wrap="square">
+            <a:spAutoFit/>
+          </a:bodyPr>
+          <a:lstStyle/>
+          <a:p>
+            <a:pPr algn="l">
+              <a:defRPr sz="1600" b="1">
+                <a:solidFill>
+                  <a:srgbClr val="0D47A1"/>
+                </a:solidFill>
+              </a:defRPr>
+            </a:pPr>
+            <a:r>
+              <a:t>DESIGN HIGHLIGHTS</a:t>
+            </a:r>
+          </a:p>
+        </p:txBody>
+      </p:sp>
+      <p:sp>
+        <p:nvSpPr>
+          <p:cNvPr id="7" name="TextBox 6"/>
+          <p:cNvSpPr txBox="1"/>
+          <p:nvPr/>
+        </p:nvSpPr>
+        <p:spPr>
+          <a:xfrm>
+            <a:off x="8229600" y="1828800"/>
+            <a:ext cx="3657600" cy="4572000"/>
+          </a:xfrm>
+          <a:prstGeom prst="rect">
+            <a:avLst/>
+          </a:prstGeom>
+          <a:noFill/>
+        </p:spPr>
+        <p:txBody>
+          <a:bodyPr wrap="square">
+            <a:spAutoFit/>
+          </a:bodyPr>
+          <a:lstStyle/>
+          <a:p>
+            <a:pPr>
+              <a:spcAft>
+                <a:spcPts val="800"/>
+              </a:spcAft>
+              <a:defRPr sz="1200">
+                <a:solidFill>
+                  <a:srgbClr val="212121"/>
+                </a:solidFill>
+              </a:defRPr>
+            </a:pPr>
+            <a:r>
+              <a:t>CLI provides unified interface</a:t>
+            </a:r>
+          </a:p>
+          <a:p>
+            <a:pPr>
+              <a:spcAft>
+                <a:spcPts val="800"/>
+              </a:spcAft>
+              <a:defRPr sz="1200">
+                <a:solidFill>
+                  <a:srgbClr val="212121"/>
+                </a:solidFill>
+              </a:defRPr>
+            </a:pPr>
+          </a:p>
+          <a:p>
+            <a:pPr>
+              <a:spcAft>
+                <a:spcPts val="800"/>
+              </a:spcAft>
+              <a:defRPr sz="1200">
+                <a:solidFill>
+                  <a:srgbClr val="212121"/>
+                </a:solidFill>
+              </a:defRPr>
+            </a:pPr>
+            <a:r>
+              <a:t>Three core managers:</a:t>
+            </a:r>
+          </a:p>
+          <a:p>
+            <a:pPr>
+              <a:spcAft>
+                <a:spcPts val="800"/>
+              </a:spcAft>
+              <a:defRPr sz="1200">
+                <a:solidFill>
+                  <a:srgbClr val="212121"/>
+                </a:solidFill>
+              </a:defRPr>
+            </a:pPr>
+            <a:r>
+              <a:t>  - Projects (isolation)</a:t>
+            </a:r>
+          </a:p>
+          <a:p>
+            <a:pPr>
+              <a:spcAft>
+                <a:spcPts val="800"/>
+              </a:spcAft>
+              <a:defRPr sz="1200">
+                <a:solidFill>
+                  <a:srgbClr val="212121"/>
+                </a:solidFill>
+              </a:defRPr>
+            </a:pPr>
+            <a:r>
+              <a:t>  - Specs (flexibility)</a:t>
+            </a:r>
+          </a:p>
+          <a:p>
+            <a:pPr>
+              <a:spcAft>
+                <a:spcPts val="800"/>
+              </a:spcAft>
+              <a:defRPr sz="1200">
+                <a:solidFill>
+                  <a:srgbClr val="212121"/>
+                </a:solidFill>
+              </a:defRPr>
+            </a:pPr>
+            <a:r>
+              <a:t>  - Agents (specialization)</a:t>
+            </a:r>
+          </a:p>
+          <a:p>
+            <a:pPr>
+              <a:spcAft>
+                <a:spcPts val="800"/>
+              </a:spcAft>
+              <a:defRPr sz="1200">
+                <a:solidFill>
+                  <a:srgbClr val="212121"/>
+                </a:solidFill>
+              </a:defRPr>
+            </a:pPr>
+          </a:p>
+          <a:p>
+            <a:pPr>
+              <a:spcAft>
+                <a:spcPts val="800"/>
+              </a:spcAft>
+              <a:defRPr sz="1200">
+                <a:solidFill>
+                  <a:srgbClr val="212121"/>
+                </a:solidFill>
+              </a:defRPr>
+            </a:pPr>
+            <a:r>
+              <a:t>Orchestration engine:</a:t>
+            </a:r>
+          </a:p>
+          <a:p>
+            <a:pPr>
+              <a:spcAft>
+                <a:spcPts val="800"/>
+              </a:spcAft>
+              <a:defRPr sz="1200">
+                <a:solidFill>
+                  <a:srgbClr val="212121"/>
+                </a:solidFill>
+              </a:defRPr>
+            </a:pPr>
+            <a:r>
+              <a:t>  - DAG task scheduling</a:t>
+            </a:r>
+          </a:p>
+          <a:p>
+            <a:pPr>
+              <a:spcAft>
+                <a:spcPts val="800"/>
+              </a:spcAft>
+              <a:defRPr sz="1200">
+                <a:solidFill>
+                  <a:srgbClr val="212121"/>
+                </a:solidFill>
+              </a:defRPr>
+            </a:pPr>
+            <a:r>
+              <a:t>  - Escalation control</a:t>
+            </a:r>
+          </a:p>
+          <a:p>
+            <a:pPr>
+              <a:spcAft>
+                <a:spcPts val="800"/>
+              </a:spcAft>
+              <a:defRPr sz="1200">
+                <a:solidFill>
+                  <a:srgbClr val="212121"/>
+                </a:solidFill>
+              </a:defRPr>
+            </a:pPr>
+            <a:r>
+              <a:t>  - Research coordination</a:t>
+            </a:r>
+          </a:p>
+          <a:p>
+            <a:pPr>
+              <a:spcAft>
+                <a:spcPts val="800"/>
+              </a:spcAft>
+              <a:defRPr sz="1200">
+                <a:solidFill>
+                  <a:srgbClr val="212121"/>
+                </a:solidFill>
+              </a:defRPr>
+            </a:pPr>
+          </a:p>
+          <a:p>
+            <a:pPr>
+              <a:spcAft>
+                <a:spcPts val="800"/>
+              </a:spcAft>
+              <a:defRPr sz="1200">
+                <a:solidFill>
+                  <a:srgbClr val="212121"/>
+                </a:solidFill>
+              </a:defRPr>
+            </a:pPr>
+            <a:r>
+              <a:t>SQLite for persistence</a:t>
+            </a:r>
+          </a:p>
+          <a:p>
+            <a:pPr>
+              <a:spcAft>
+                <a:spcPts val="800"/>
+              </a:spcAft>
+              <a:defRPr sz="1200">
+                <a:solidFill>
+                  <a:srgbClr val="212121"/>
+                </a:solidFill>
+              </a:defRPr>
+            </a:pPr>
+            <a:r>
+              <a:t>JSON logs for observability</a:t>
+            </a:r>
+          </a:p>
+        </p:txBody>
+      </p:sp>
     </p:spTree>
   </p:cSld>
   <p:clrMapOvr>
@@ -7923,8 +8450,8 @@
         </p:blipFill>
         <p:spPr>
           <a:xfrm>
-            <a:off x="274320" y="1097280"/>
-            <a:ext cx="7315200" cy="5489484"/>
+            <a:off x="182880" y="1097280"/>
+            <a:ext cx="6400800" cy="4803298"/>
           </a:xfrm>
           <a:prstGeom prst="rect">
             <a:avLst/>
@@ -7939,8 +8466,8 @@
         </p:nvSpPr>
         <p:spPr>
           <a:xfrm>
-            <a:off x="7772400" y="1371600"/>
-            <a:ext cx="4114800" cy="365760"/>
+            <a:off x="6858000" y="1280160"/>
+            <a:ext cx="5029200" cy="365760"/>
           </a:xfrm>
           <a:prstGeom prst="rect">
             <a:avLst/>
@@ -7961,7 +8488,7 @@
               </a:defRPr>
             </a:pPr>
             <a:r>
-              <a:t>WHY THIS WORKS</a:t>
+              <a:t>HOW IT WORKS</a:t>
             </a:r>
           </a:p>
         </p:txBody>
@@ -7974,8 +8501,8 @@
         </p:nvSpPr>
         <p:spPr>
           <a:xfrm>
-            <a:off x="7772400" y="1828800"/>
-            <a:ext cx="4114800" cy="3657600"/>
+            <a:off x="6858000" y="1737360"/>
+            <a:ext cx="5029200" cy="2560320"/>
           </a:xfrm>
           <a:prstGeom prst="rect">
             <a:avLst/>
@@ -7999,7 +8526,7 @@
               </a:defRPr>
             </a:pPr>
             <a:r>
-              <a:t>70%+ tasks succeed with Sonnet</a:t>
+              <a:t>1. Start with Sonnet (fast, cheap)</a:t>
             </a:r>
           </a:p>
           <a:p>
@@ -8014,7 +8541,7 @@
               </a:defRPr>
             </a:pPr>
             <a:r>
-              <a:t>Only escalate on actual failures</a:t>
+              <a:t>   - 3 attempts before escalating</a:t>
             </a:r>
           </a:p>
           <a:p>
@@ -8029,7 +8556,7 @@
               </a:defRPr>
             </a:pPr>
             <a:r>
-              <a:t>Diagnosis identifies root cause</a:t>
+              <a:t>   - Handles 70%+ of tasks</a:t>
             </a:r>
           </a:p>
           <a:p>
@@ -8043,9 +8570,6 @@
                 </a:solidFill>
               </a:defRPr>
             </a:pPr>
-            <a:r>
-              <a:t>Actions are targeted, not random</a:t>
-            </a:r>
           </a:p>
           <a:p>
             <a:pPr>
@@ -8058,6 +8582,9 @@
                 </a:solidFill>
               </a:defRPr>
             </a:pPr>
+            <a:r>
+              <a:t>2. Escalate to Opus if needed</a:t>
+            </a:r>
           </a:p>
           <a:p>
             <a:pPr>
@@ -8071,7 +8598,7 @@
               </a:defRPr>
             </a:pPr>
             <a:r>
-              <a:t>COST OPTIMIZATION:</a:t>
+              <a:t>   - More capable reasoning</a:t>
             </a:r>
           </a:p>
           <a:p>
@@ -8086,7 +8613,7 @@
               </a:defRPr>
             </a:pPr>
             <a:r>
-              <a:t>- Sonnet: $3/$15 per 1M tokens</a:t>
+              <a:t>   - 3 more attempts</a:t>
             </a:r>
           </a:p>
           <a:p>
@@ -8100,9 +8627,6 @@
                 </a:solidFill>
               </a:defRPr>
             </a:pPr>
-            <a:r>
-              <a:t>- Opus: $15/$75 per 1M tokens</a:t>
-            </a:r>
           </a:p>
           <a:p>
             <a:pPr>
@@ -8116,7 +8640,140 @@
               </a:defRPr>
             </a:pPr>
             <a:r>
-              <a:t>- 5x cheaper for most tasks</a:t>
+              <a:t>3. Diagnosis on persistent failure</a:t>
+            </a:r>
+          </a:p>
+          <a:p>
+            <a:pPr>
+              <a:spcAft>
+                <a:spcPts val="800"/>
+              </a:spcAft>
+              <a:defRPr sz="1200">
+                <a:solidFill>
+                  <a:srgbClr val="212121"/>
+                </a:solidFill>
+              </a:defRPr>
+            </a:pPr>
+            <a:r>
+              <a:t>   - Analyzes root cause</a:t>
+            </a:r>
+          </a:p>
+          <a:p>
+            <a:pPr>
+              <a:spcAft>
+                <a:spcPts val="800"/>
+              </a:spcAft>
+              <a:defRPr sz="1200">
+                <a:solidFill>
+                  <a:srgbClr val="212121"/>
+                </a:solidFill>
+              </a:defRPr>
+            </a:pPr>
+            <a:r>
+              <a:t>   - Takes targeted action</a:t>
+            </a:r>
+          </a:p>
+        </p:txBody>
+      </p:sp>
+      <p:sp>
+        <p:nvSpPr>
+          <p:cNvPr id="8" name="TextBox 7"/>
+          <p:cNvSpPr txBox="1"/>
+          <p:nvPr/>
+        </p:nvSpPr>
+        <p:spPr>
+          <a:xfrm>
+            <a:off x="6858000" y="4389120"/>
+            <a:ext cx="5029200" cy="365760"/>
+          </a:xfrm>
+          <a:prstGeom prst="rect">
+            <a:avLst/>
+          </a:prstGeom>
+          <a:noFill/>
+        </p:spPr>
+        <p:txBody>
+          <a:bodyPr wrap="square">
+            <a:spAutoFit/>
+          </a:bodyPr>
+          <a:lstStyle/>
+          <a:p>
+            <a:pPr algn="l">
+              <a:defRPr sz="1400" b="1">
+                <a:solidFill>
+                  <a:srgbClr val="4CAF50"/>
+                </a:solidFill>
+              </a:defRPr>
+            </a:pPr>
+            <a:r>
+              <a:t>COST BENEFIT</a:t>
+            </a:r>
+          </a:p>
+        </p:txBody>
+      </p:sp>
+      <p:sp>
+        <p:nvSpPr>
+          <p:cNvPr id="9" name="TextBox 8"/>
+          <p:cNvSpPr txBox="1"/>
+          <p:nvPr/>
+        </p:nvSpPr>
+        <p:spPr>
+          <a:xfrm>
+            <a:off x="6858000" y="4754880"/>
+            <a:ext cx="5029200" cy="1097280"/>
+          </a:xfrm>
+          <a:prstGeom prst="rect">
+            <a:avLst/>
+          </a:prstGeom>
+          <a:noFill/>
+        </p:spPr>
+        <p:txBody>
+          <a:bodyPr wrap="square">
+            <a:spAutoFit/>
+          </a:bodyPr>
+          <a:lstStyle/>
+          <a:p>
+            <a:pPr>
+              <a:spcAft>
+                <a:spcPts val="800"/>
+              </a:spcAft>
+              <a:defRPr sz="1200">
+                <a:solidFill>
+                  <a:srgbClr val="212121"/>
+                </a:solidFill>
+              </a:defRPr>
+            </a:pPr>
+            <a:r>
+              <a:t>Sonnet: $3/$15 per 1M tokens</a:t>
+            </a:r>
+          </a:p>
+          <a:p>
+            <a:pPr>
+              <a:spcAft>
+                <a:spcPts val="800"/>
+              </a:spcAft>
+              <a:defRPr sz="1200">
+                <a:solidFill>
+                  <a:srgbClr val="212121"/>
+                </a:solidFill>
+              </a:defRPr>
+            </a:pPr>
+            <a:r>
+              <a:t>Opus: $15/$75 per 1M tokens</a:t>
+            </a:r>
+          </a:p>
+          <a:p>
+            <a:pPr>
+              <a:spcAft>
+                <a:spcPts val="800"/>
+              </a:spcAft>
+              <a:defRPr sz="1200">
+                <a:solidFill>
+                  <a:srgbClr val="212121"/>
+                </a:solidFill>
+              </a:defRPr>
+            </a:pPr>
+            <a:r>
+              <a:t>5x savings on most tasks!</a:t>
             </a:r>
           </a:p>
         </p:txBody>
@@ -8509,8 +9166,8 @@
         </p:nvSpPr>
         <p:spPr>
           <a:xfrm>
-            <a:off x="457200" y="5029200"/>
-            <a:ext cx="10972800" cy="1371600"/>
+            <a:off x="457200" y="5303520"/>
+            <a:ext cx="10972800" cy="731520"/>
           </a:xfrm>
           <a:prstGeom prst="rect">
             <a:avLst/>
@@ -8527,59 +9184,14 @@
               <a:spcAft>
                 <a:spcPts val="800"/>
               </a:spcAft>
-              <a:defRPr sz="1300">
+              <a:defRPr sz="1200">
                 <a:solidFill>
                   <a:srgbClr val="212121"/>
                 </a:solidFill>
               </a:defRPr>
             </a:pPr>
             <a:r>
-              <a:t>Independent tasks execute concurrently</a:t>
-            </a:r>
-          </a:p>
-          <a:p>
-            <a:pPr>
-              <a:spcAft>
-                <a:spcPts val="800"/>
-              </a:spcAft>
-              <a:defRPr sz="1300">
-                <a:solidFill>
-                  <a:srgbClr val="212121"/>
-                </a:solidFill>
-              </a:defRPr>
-            </a:pPr>
-            <a:r>
-              <a:t>Dependency resolution via topological sort</a:t>
-            </a:r>
-          </a:p>
-          <a:p>
-            <a:pPr>
-              <a:spcAft>
-                <a:spcPts val="800"/>
-              </a:spcAft>
-              <a:defRPr sz="1300">
-                <a:solidFill>
-                  <a:srgbClr val="212121"/>
-                </a:solidFill>
-              </a:defRPr>
-            </a:pPr>
-            <a:r>
-              <a:t>Each task gets isolated session</a:t>
-            </a:r>
-          </a:p>
-          <a:p>
-            <a:pPr>
-              <a:spcAft>
-                <a:spcPts val="800"/>
-              </a:spcAft>
-              <a:defRPr sz="1300">
-                <a:solidFill>
-                  <a:srgbClr val="212121"/>
-                </a:solidFill>
-              </a:defRPr>
-            </a:pPr>
-            <a:r>
-              <a:t>Failures don't block independent work</a:t>
+              <a:t>Independent tasks execute concurrently  |  Dependency resolution via topological sort  |  Each task gets isolated session  |  Failures don't block independent work</a:t>
             </a:r>
           </a:p>
         </p:txBody>

</xml_diff>